<commit_message>
fix: validate final presentation package
</commit_message>
<xml_diff>
--- a/docs/presentation/final/output/economic-event-intelligence-final.pptx
+++ b/docs/presentation/final/output/economic-event-intelligence-final.pptx
@@ -1770,6 +1770,38 @@
 </p:sldLayout>
 </file>
 
+<file path=ppt/slideLayouts/slideLayout2.xml><?xml version="1.0" encoding="utf-8"?>
+<p:sldLayout xmlns:a="http://schemas.openxmlformats.org/drawingml/2006/main" xmlns:r="http://schemas.openxmlformats.org/officeDocument/2006/relationships" xmlns:p="http://schemas.openxmlformats.org/presentationml/2006/main" preserve="1">
+  <p:cSld name="FINAL_DECK_MASTER">
+    <p:bg>
+      <p:bgPr>
+        <a:solidFill>
+          <a:srgbClr val="F7F5F1"/>
+        </a:solidFill>
+      </p:bgPr>
+    </p:bg>
+    <p:spTree>
+      <p:nvGrpSpPr>
+        <p:cNvPr id="1" name=""/>
+        <p:cNvGrpSpPr/>
+        <p:nvPr/>
+      </p:nvGrpSpPr>
+      <p:grpSpPr>
+        <a:xfrm>
+          <a:off x="0" y="0"/>
+          <a:ext cx="0" cy="0"/>
+          <a:chOff x="0" y="0"/>
+          <a:chExt cx="0" cy="0"/>
+        </a:xfrm>
+      </p:grpSpPr>
+    </p:spTree>
+  </p:cSld>
+  <p:clrMapOvr>
+    <a:masterClrMapping/>
+  </p:clrMapOvr>
+</p:sldLayout>
+</file>
+
 <file path=ppt/slideMasters/slideMaster1.xml><?xml version="1.0" encoding="utf-8"?>
 <p:sldMaster xmlns:a="http://schemas.openxmlformats.org/drawingml/2006/main" xmlns:r="http://schemas.openxmlformats.org/officeDocument/2006/relationships" xmlns:p="http://schemas.openxmlformats.org/presentationml/2006/main">
   <p:cSld>
@@ -1792,6 +1824,7 @@
   <p:clrMap bg1="lt1" tx1="dk1" bg2="lt2" tx2="dk2" accent1="accent1" accent2="accent2" accent3="accent3" accent4="accent4" accent5="accent5" accent6="accent6" hlink="hlink" folHlink="folHlink"/>
   <p:sldLayoutIdLst>
     <p:sldLayoutId id="2147483649" r:id="rId1"/>
+    <p:sldLayoutId id="2147483650" r:id="rId2"/>
   </p:sldLayoutIdLst>
   <p:hf sldNum="0" hdr="0" ftr="0" dt="0"/>
   <p:txStyles>

</xml_diff>